<commit_message>
refactor: clean up repetitive phrasing and AI terms in codebase, reports, and slides
</commit_message>
<xml_diff>
--- a/MEE344_Machine_Learning_Presentation.pptx
+++ b/MEE344_Machine_Learning_Presentation.pptx
@@ -3200,7 +3200,7 @@
               </a:defRPr>
             </a:pPr>
             <a:r>
-              <a:t>An End-to-End Machine Learning Pipeline for the Turkish Power Grid</a:t>
+              <a:t>Predictive Modeling on the Turkish Power Grid</a:t>
             </a:r>
           </a:p>
         </p:txBody>
@@ -5055,7 +5055,7 @@
             </a:r>
             <a:br/>
             <a:r>
-              <a:t>  - In both Linear Regression and XGBoost, **`Toplam_lag_1`** (t-1 hour demand) and **`Toplam_lag_24`** (t-24 hour demand) are the top two features.</a:t>
+              <a:t>  - In both Linear Regression and XGBoost, Toplam_lag_1 (t-1 hour demand) and Toplam_lag_24 (t-24 hour demand) are the top two features.</a:t>
             </a:r>
             <a:br/>
             <a:r>
@@ -5064,11 +5064,11 @@
             <a:br/>
             <a:br/>
             <a:r>
-              <a:t>• **Trigonometric saatin (sin/cos) katkısı**:</a:t>
-            </a:r>
-            <a:br/>
-            <a:r>
-              <a:t>  - Cyclical hour coordinates (`Hour_sin`, `Hour_cos`) act as powerful predictors, letting models identify smooth peak/vadi transitions without creating ordinal bias.</a:t>
+              <a:t>• **Trigonometric Cyclical Time Contribution**:</a:t>
+            </a:r>
+            <a:br/>
+            <a:r>
+              <a:t>  - Cyclical hour coordinates (Hour_sin, Hour_cos) act as powerful predictors, letting models identify smooth peak/valley transitions without creating ordinal bias.</a:t>
             </a:r>
           </a:p>
         </p:txBody>
@@ -5290,7 +5290,7 @@
               </a:defRPr>
             </a:pPr>
             <a:r>
-              <a:t>Real-World Sektörel Etki</a:t>
+              <a:t>Real-World Sectoral Impact</a:t>
             </a:r>
           </a:p>
           <a:p>
@@ -5306,7 +5306,7 @@
               </a:defRPr>
             </a:pPr>
             <a:r>
-              <a:t>• **Grid Dispatching Optimization**: Allows TEİAŞ or utility companies to efficiently schedule baseload termik generators, preventing costly hot start-ups.</a:t>
+              <a:t>• **Grid Dispatching Optimization**: Allows transmission system operators (TSOs) or utility companies to efficiently schedule baseload thermal generators, preventing costly hot start-ups.</a:t>
             </a:r>
             <a:br/>
             <a:br/>
@@ -5316,7 +5316,7 @@
             <a:br/>
             <a:br/>
             <a:r>
-              <a:t>• **Outage Management**: Enables planning scheduled maintenance during demand vadileri (valleys) rather than peak hours.</a:t>
+              <a:t>• **Outage Management**: Enables planning scheduled maintenance during demand valleys rather than peak hours.</a:t>
             </a:r>
           </a:p>
         </p:txBody>
@@ -5544,7 +5544,7 @@
               </a:defRPr>
             </a:pPr>
             <a:r>
-              <a:t>Hourly Grid Load Forecasting Pipeline Successfully Deployed</a:t>
+              <a:t>Hourly Grid Load Forecasting Project Completed</a:t>
             </a:r>
           </a:p>
           <a:p>
@@ -5793,7 +5793,7 @@
               </a:defRPr>
             </a:pPr>
             <a:r>
-              <a:t>• Develop an optimized, end-to-end ML pipeline with complete reproducibility.</a:t>
+              <a:t>• Develop an optimized, machine learning model with complete reproducibility.</a:t>
             </a:r>
             <a:br/>
             <a:r>
@@ -7113,7 +7113,7 @@
               </a:defRPr>
             </a:pPr>
             <a:r>
-              <a:t>1. Diurnal (Daily) Tüketim Döngüsü:</a:t>
+              <a:t>1. Diurnal (Daily) Consumption Cycle:</a:t>
             </a:r>
             <a:br/>
             <a:r>
@@ -7498,25 +7498,93 @@
               </a:defRPr>
             </a:pPr>
             <a:r>
-              <a:t>• **Zero Missing Values Verified**: The dataset has 100% complete records. To ensure future robustness against grid reporting losses, a forward-fill (`ffill`) followed by backward-fill (`bfill`) fallback block was engineered.</a:t>
-            </a:r>
-            <a:br/>
-            <a:br/>
-            <a:r>
-              <a:t>• **Scaling for Linear Models**: The inputs are scaled using `StandardScaler` to have zero mean and unit variance:</a:t>
-            </a:r>
-            <a:br/>
-            <a:r>
-              <a:t>  $$z = \frac{x - \mu}{\sigma}$$</a:t>
-            </a:r>
-            <a:br/>
-            <a:r>
+              <a:t>• </a:t>
+            </a:r>
+            <a:r>
+              <a:rPr b="1"/>
+              <a:t>Zero Missing Values Verified</a:t>
+            </a:r>
+            <a:r>
+              <a:t>: The dataset has 100% complete records. To ensure future robustness against grid reporting losses, a forward-fill (ffill) followed by backward-fill (bfill) fallback block was engineered.</a:t>
+            </a:r>
+          </a:p>
+          <a:p>
+            <a:pPr>
+              <a:spcBef>
+                <a:spcPts val="1200"/>
+              </a:spcBef>
+              <a:defRPr sz="1300">
+                <a:solidFill>
+                  <a:srgbClr val="0F172A"/>
+                </a:solidFill>
+                <a:latin typeface="Calibri"/>
+              </a:defRPr>
+            </a:pPr>
+            <a:r>
+              <a:t>• </a:t>
+            </a:r>
+            <a:r>
+              <a:rPr b="1"/>
+              <a:t>Scaling for Linear Models</a:t>
+            </a:r>
+            <a:r>
+              <a:t>: The inputs are scaled using StandardScaler to have zero mean (μ = 0) and unit variance (σ = 1) using the formula:</a:t>
+            </a:r>
+          </a:p>
+          <a:p>
+            <a:pPr algn="ctr">
+              <a:spcBef>
+                <a:spcPts val="800"/>
+              </a:spcBef>
+              <a:spcAft>
+                <a:spcPts val="800"/>
+              </a:spcAft>
+            </a:pPr>
+            <a:r>
+              <a:rPr sz="1600" b="1">
+                <a:solidFill>
+                  <a:srgbClr val="2563EB"/>
+                </a:solidFill>
+                <a:latin typeface="Courier New"/>
+              </a:rPr>
+              <a:t>   z = (x - μ) / σ   </a:t>
+            </a:r>
+          </a:p>
+          <a:p>
+            <a:pPr>
+              <a:defRPr sz="1200">
+                <a:solidFill>
+                  <a:srgbClr val="64748B"/>
+                </a:solidFill>
+                <a:latin typeface="Calibri"/>
+              </a:defRPr>
+            </a:pPr>
+            <a:r>
+              <a:rPr i="1"/>
               <a:t>  *Necessary to ensure the regularized Linear Regression coefficients can be compared directly for feature importance.*</a:t>
             </a:r>
-            <a:br/>
-            <a:br/>
-            <a:r>
-              <a:t>• **Tree-based Robustness**: XGBoost is scale-invariant, hence it trains directly on raw, unscaled features, preserving raw value context.</a:t>
+          </a:p>
+          <a:p>
+            <a:pPr>
+              <a:spcBef>
+                <a:spcPts val="1200"/>
+              </a:spcBef>
+              <a:defRPr sz="1300">
+                <a:solidFill>
+                  <a:srgbClr val="0F172A"/>
+                </a:solidFill>
+                <a:latin typeface="Calibri"/>
+              </a:defRPr>
+            </a:pPr>
+            <a:r>
+              <a:t>• </a:t>
+            </a:r>
+            <a:r>
+              <a:rPr b="1"/>
+              <a:t>Tree-based Robustness</a:t>
+            </a:r>
+            <a:r>
+              <a:t>: XGBoost is scale-invariant, hence it trains directly on raw, unscaled features, preserving raw value context.</a:t>
             </a:r>
           </a:p>
         </p:txBody>
@@ -7749,19 +7817,141 @@
               </a:defRPr>
             </a:pPr>
             <a:r>
-              <a:t>• We transform time coordinates onto a 2D unit circle using Sine and Cosine transformations.</a:t>
-            </a:r>
-            <a:br/>
-            <a:r>
-              <a:t>• **Hour transformation**:</a:t>
-            </a:r>
-            <a:br/>
-            <a:r>
-              <a:t>  $$Hour_{sin} = \sin\left(\frac{2\pi \cdot Hour}{24}\right), \quad Hour_{cos} = \cos\left(\frac{2\pi \cdot Hour}{24}_x000D_ight)$$</a:t>
-            </a:r>
-            <a:br/>
-            <a:r>
-              <a:t>• Applied to **Hour** (24-hour cycle), **DayOfWeek** (7-day cycle), and **Month** (12-month cycle).</a:t>
+              <a:t>• We transform periodic time coordinates onto a 2D unit circle using trigonometric Sine and Cosine transformations.</a:t>
+            </a:r>
+          </a:p>
+          <a:p>
+            <a:pPr>
+              <a:spcBef>
+                <a:spcPts val="1000"/>
+              </a:spcBef>
+              <a:defRPr sz="1400">
+                <a:solidFill>
+                  <a:srgbClr val="0F172A"/>
+                </a:solidFill>
+                <a:latin typeface="Calibri"/>
+              </a:defRPr>
+            </a:pPr>
+            <a:r>
+              <a:t>• </a:t>
+            </a:r>
+            <a:r>
+              <a:rPr b="1"/>
+              <a:t>Hour Cyclical Transformations</a:t>
+            </a:r>
+            <a:r>
+              <a:t>:</a:t>
+            </a:r>
+          </a:p>
+          <a:p>
+            <a:pPr algn="l">
+              <a:spcBef>
+                <a:spcPts val="600"/>
+              </a:spcBef>
+              <a:spcAft>
+                <a:spcPts val="200"/>
+              </a:spcAft>
+            </a:pPr>
+            <a:r>
+              <a:rPr sz="1400" b="1">
+                <a:solidFill>
+                  <a:srgbClr val="2563EB"/>
+                </a:solidFill>
+                <a:latin typeface="Courier New"/>
+              </a:rPr>
+              <a:t>   Hour</a:t>
+            </a:r>
+            <a:r>
+              <a:rPr sz="1400" b="1">
+                <a:solidFill>
+                  <a:srgbClr val="2563EB"/>
+                </a:solidFill>
+                <a:latin typeface="Courier New"/>
+              </a:rPr>
+              <a:t>sin</a:t>
+            </a:r>
+            <a:r>
+              <a:rPr sz="1400" b="1">
+                <a:solidFill>
+                  <a:srgbClr val="2563EB"/>
+                </a:solidFill>
+                <a:latin typeface="Courier New"/>
+              </a:rPr>
+              <a:t> = sin( 2 · π · Hour / 24 )</a:t>
+            </a:r>
+          </a:p>
+          <a:p>
+            <a:pPr algn="l">
+              <a:spcBef>
+                <a:spcPts val="200"/>
+              </a:spcBef>
+              <a:spcAft>
+                <a:spcPts val="600"/>
+              </a:spcAft>
+            </a:pPr>
+            <a:r>
+              <a:rPr sz="1400" b="1">
+                <a:solidFill>
+                  <a:srgbClr val="2563EB"/>
+                </a:solidFill>
+                <a:latin typeface="Courier New"/>
+              </a:rPr>
+              <a:t>   Hour</a:t>
+            </a:r>
+            <a:r>
+              <a:rPr sz="1400" b="1">
+                <a:solidFill>
+                  <a:srgbClr val="2563EB"/>
+                </a:solidFill>
+                <a:latin typeface="Courier New"/>
+              </a:rPr>
+              <a:t>cos</a:t>
+            </a:r>
+            <a:r>
+              <a:rPr sz="1400" b="1">
+                <a:solidFill>
+                  <a:srgbClr val="2563EB"/>
+                </a:solidFill>
+                <a:latin typeface="Courier New"/>
+              </a:rPr>
+              <a:t> = cos( 2 · π · Hour / 24 )</a:t>
+            </a:r>
+          </a:p>
+          <a:p>
+            <a:pPr>
+              <a:spcBef>
+                <a:spcPts val="1000"/>
+              </a:spcBef>
+              <a:defRPr sz="1400">
+                <a:solidFill>
+                  <a:srgbClr val="0F172A"/>
+                </a:solidFill>
+                <a:latin typeface="Calibri"/>
+              </a:defRPr>
+            </a:pPr>
+            <a:r>
+              <a:t>• This encoding is applied to </a:t>
+            </a:r>
+            <a:r>
+              <a:rPr b="1"/>
+              <a:t>Hour</a:t>
+            </a:r>
+            <a:r>
+              <a:t> (24-hour cycle), </a:t>
+            </a:r>
+            <a:r>
+              <a:rPr b="1"/>
+              <a:t>DayOfWeek</a:t>
+            </a:r>
+            <a:r>
+              <a:t> (7-day cycle), and </a:t>
+            </a:r>
+            <a:r>
+              <a:rPr b="1"/>
+              <a:t>Month</a:t>
+            </a:r>
+            <a:r>
+              <a:t> (12-month cycle).</a:t>
             </a:r>
           </a:p>
         </p:txBody>

</xml_diff>